<commit_message>
actualizacion guia y ppt
</commit_message>
<xml_diff>
--- a/Fase 1/Evidencias Grupales/Presentación Proyecto.pptx
+++ b/Fase 1/Evidencias Grupales/Presentación Proyecto.pptx
@@ -1933,7 +1933,7 @@
                 <a:ea typeface="Georgia" pitchFamily="34" charset="-122"/>
                 <a:cs typeface="Georgia" pitchFamily="34" charset="-120"/>
               </a:rPr>
-              <a:t>PARA BARBERÍA</a:t>
+              <a:t>PARA BARBERÍA BIG BOYS</a:t>
             </a:r>
             <a:endParaRPr lang="en-US" sz="4000" dirty="0"/>
           </a:p>
@@ -2721,9 +2721,6 @@
           <a:bodyPr wrap="square" lIns="0" tIns="0" rIns="0" bIns="0" rtlCol="0" anchor="ctr"/>
           <a:lstStyle/>
           <a:p>
-            <a:pPr marL="0" indent="0">
-              <a:buNone/>
-            </a:pPr>
             <a:r>
               <a:rPr lang="en-US" sz="900" kern="0" spc="100" dirty="0">
                 <a:solidFill>
@@ -2733,7 +2730,7 @@
                 <a:ea typeface="Georgia" pitchFamily="34" charset="-122"/>
                 <a:cs typeface="Georgia" pitchFamily="34" charset="-120"/>
               </a:rPr>
-              <a:t>PROYECTO BARBERÍA · WEB + APP MÓVIL</a:t>
+              <a:t>PROYECTO BARBERÍA BIG BOYS · WEB + APP MÓVIL</a:t>
             </a:r>
             <a:endParaRPr lang="en-US" sz="900" dirty="0"/>
           </a:p>
@@ -4030,9 +4027,6 @@
           <a:bodyPr wrap="square" lIns="0" tIns="0" rIns="0" bIns="0" rtlCol="0" anchor="ctr"/>
           <a:lstStyle/>
           <a:p>
-            <a:pPr marL="0" indent="0">
-              <a:buNone/>
-            </a:pPr>
             <a:r>
               <a:rPr lang="en-US" sz="900" kern="0" spc="100" dirty="0">
                 <a:solidFill>
@@ -4042,7 +4036,7 @@
                 <a:ea typeface="Georgia" pitchFamily="34" charset="-122"/>
                 <a:cs typeface="Georgia" pitchFamily="34" charset="-120"/>
               </a:rPr>
-              <a:t>PROYECTO BARBERÍA · WEB + APP MÓVIL</a:t>
+              <a:t>PROYECTO BARBERÍA BIG BOYS · WEB + APP MÓVIL</a:t>
             </a:r>
             <a:endParaRPr lang="en-US" sz="900" dirty="0"/>
           </a:p>
@@ -5157,9 +5151,6 @@
           <a:bodyPr wrap="square" lIns="0" tIns="0" rIns="0" bIns="0" rtlCol="0" anchor="ctr"/>
           <a:lstStyle/>
           <a:p>
-            <a:pPr marL="0" indent="0">
-              <a:buNone/>
-            </a:pPr>
             <a:r>
               <a:rPr lang="en-US" sz="900" kern="0" spc="100" dirty="0">
                 <a:solidFill>
@@ -5169,7 +5160,7 @@
                 <a:ea typeface="Georgia" pitchFamily="34" charset="-122"/>
                 <a:cs typeface="Georgia" pitchFamily="34" charset="-120"/>
               </a:rPr>
-              <a:t>PROYECTO BARBERÍA · WEB + APP MÓVIL</a:t>
+              <a:t>PROYECTO BARBERÍA BIG BOYS · WEB + APP MÓVIL</a:t>
             </a:r>
             <a:endParaRPr lang="en-US" sz="900" dirty="0"/>
           </a:p>
@@ -5976,9 +5967,6 @@
           <a:bodyPr wrap="square" lIns="0" tIns="0" rIns="0" bIns="0" rtlCol="0" anchor="ctr"/>
           <a:lstStyle/>
           <a:p>
-            <a:pPr marL="0" indent="0">
-              <a:buNone/>
-            </a:pPr>
             <a:r>
               <a:rPr lang="en-US" sz="900" kern="0" spc="100" dirty="0">
                 <a:solidFill>
@@ -5988,7 +5976,7 @@
                 <a:ea typeface="Georgia" pitchFamily="34" charset="-122"/>
                 <a:cs typeface="Georgia" pitchFamily="34" charset="-120"/>
               </a:rPr>
-              <a:t>PROYECTO BARBERÍA · WEB + APP MÓVIL</a:t>
+              <a:t>PROYECTO BARBERÍA BIG BOYS · WEB + APP MÓVIL</a:t>
             </a:r>
             <a:endParaRPr lang="en-US" sz="900" dirty="0"/>
           </a:p>
@@ -6441,9 +6429,6 @@
           <a:bodyPr wrap="square" lIns="0" tIns="0" rIns="0" bIns="0" rtlCol="0" anchor="ctr"/>
           <a:lstStyle/>
           <a:p>
-            <a:pPr marL="0" indent="0">
-              <a:buNone/>
-            </a:pPr>
             <a:r>
               <a:rPr lang="en-US" sz="900" kern="0" spc="100" dirty="0">
                 <a:solidFill>
@@ -6453,7 +6438,7 @@
                 <a:ea typeface="Georgia" pitchFamily="34" charset="-122"/>
                 <a:cs typeface="Georgia" pitchFamily="34" charset="-120"/>
               </a:rPr>
-              <a:t>PROYECTO BARBERÍA · WEB + APP MÓVIL</a:t>
+              <a:t>PROYECTO BARBERÍA BIG BOYS · WEB + APP MÓVIL</a:t>
             </a:r>
             <a:endParaRPr lang="en-US" sz="900" dirty="0"/>
           </a:p>
@@ -7446,7 +7431,7 @@
                 <a:ea typeface="Georgia" pitchFamily="34" charset="-122"/>
                 <a:cs typeface="Georgia" pitchFamily="34" charset="-120"/>
               </a:rPr>
-              <a:t>PROYECTO BARBERÍA · WEB + APP MÓVIL</a:t>
+              <a:t>PROYECTO BARBERÍA BIG BOYS · WEB + APP MÓVIL</a:t>
             </a:r>
             <a:endParaRPr lang="en-US" sz="900" dirty="0"/>
           </a:p>
@@ -8222,9 +8207,6 @@
           <a:bodyPr wrap="square" lIns="0" tIns="0" rIns="0" bIns="0" rtlCol="0" anchor="ctr"/>
           <a:lstStyle/>
           <a:p>
-            <a:pPr marL="0" indent="0">
-              <a:buNone/>
-            </a:pPr>
             <a:r>
               <a:rPr lang="en-US" sz="900" kern="0" spc="100" dirty="0">
                 <a:solidFill>
@@ -8234,7 +8216,7 @@
                 <a:ea typeface="Georgia" pitchFamily="34" charset="-122"/>
                 <a:cs typeface="Georgia" pitchFamily="34" charset="-120"/>
               </a:rPr>
-              <a:t>PROYECTO BARBERÍA · WEB + APP MÓVIL</a:t>
+              <a:t>PROYECTO BARBERÍA BIG BOYS · WEB + APP MÓVIL</a:t>
             </a:r>
             <a:endParaRPr lang="en-US" sz="900" dirty="0"/>
           </a:p>
@@ -8950,9 +8932,6 @@
           <a:bodyPr wrap="square" lIns="0" tIns="0" rIns="0" bIns="0" rtlCol="0" anchor="ctr"/>
           <a:lstStyle/>
           <a:p>
-            <a:pPr marL="0" indent="0">
-              <a:buNone/>
-            </a:pPr>
             <a:r>
               <a:rPr lang="en-US" sz="900" kern="0" spc="100" dirty="0">
                 <a:solidFill>
@@ -8962,7 +8941,7 @@
                 <a:ea typeface="Georgia" pitchFamily="34" charset="-122"/>
                 <a:cs typeface="Georgia" pitchFamily="34" charset="-120"/>
               </a:rPr>
-              <a:t>PROYECTO BARBERÍA · WEB + APP MÓVIL</a:t>
+              <a:t>PROYECTO BARBERÍA BIG BOYS · WEB + APP MÓVIL</a:t>
             </a:r>
             <a:endParaRPr lang="en-US" sz="900" dirty="0"/>
           </a:p>
@@ -9757,9 +9736,6 @@
           <a:bodyPr wrap="square" lIns="0" tIns="0" rIns="0" bIns="0" rtlCol="0" anchor="ctr"/>
           <a:lstStyle/>
           <a:p>
-            <a:pPr marL="0" indent="0">
-              <a:buNone/>
-            </a:pPr>
             <a:r>
               <a:rPr lang="en-US" sz="900" kern="0" spc="100" dirty="0">
                 <a:solidFill>
@@ -9769,7 +9745,7 @@
                 <a:ea typeface="Georgia" pitchFamily="34" charset="-122"/>
                 <a:cs typeface="Georgia" pitchFamily="34" charset="-120"/>
               </a:rPr>
-              <a:t>PROYECTO BARBERÍA · WEB + APP MÓVIL</a:t>
+              <a:t>PROYECTO BARBERÍA BIG BOYS · WEB + APP MÓVIL</a:t>
             </a:r>
             <a:endParaRPr lang="en-US" sz="900" dirty="0"/>
           </a:p>
@@ -9836,7 +9812,7 @@
         </p:blipFill>
         <p:spPr>
           <a:xfrm>
-            <a:off x="7003272" y="1997353"/>
+            <a:off x="9137581" y="1788931"/>
             <a:ext cx="1844555" cy="4037687"/>
           </a:xfrm>
           <a:prstGeom prst="rect">
@@ -9866,38 +9842,8 @@
         </p:blipFill>
         <p:spPr>
           <a:xfrm>
-            <a:off x="4811684" y="1990091"/>
+            <a:off x="5741223" y="1785301"/>
             <a:ext cx="1859079" cy="4044949"/>
-          </a:xfrm>
-          <a:prstGeom prst="rect">
-            <a:avLst/>
-          </a:prstGeom>
-        </p:spPr>
-      </p:pic>
-      <p:pic>
-        <p:nvPicPr>
-          <p:cNvPr id="33" name="Imagen 32">
-            <a:extLst>
-              <a:ext uri="{FF2B5EF4-FFF2-40B4-BE49-F238E27FC236}">
-                <a16:creationId xmlns:a16="http://schemas.microsoft.com/office/drawing/2014/main" id="{B4906778-AF0D-7E32-2F95-3CA9D65DD7B0}"/>
-              </a:ext>
-            </a:extLst>
-          </p:cNvPr>
-          <p:cNvPicPr>
-            <a:picLocks noChangeAspect="1"/>
-          </p:cNvPicPr>
-          <p:nvPr/>
-        </p:nvPicPr>
-        <p:blipFill>
-          <a:blip r:embed="rId5"/>
-          <a:stretch>
-            <a:fillRect/>
-          </a:stretch>
-        </p:blipFill>
-        <p:spPr>
-          <a:xfrm>
-            <a:off x="9350302" y="1974775"/>
-            <a:ext cx="2155593" cy="4075579"/>
           </a:xfrm>
           <a:prstGeom prst="rect">
             <a:avLst/>
@@ -10635,9 +10581,6 @@
           <a:bodyPr wrap="square" lIns="0" tIns="0" rIns="0" bIns="0" rtlCol="0" anchor="ctr"/>
           <a:lstStyle/>
           <a:p>
-            <a:pPr marL="0" indent="0">
-              <a:buNone/>
-            </a:pPr>
             <a:r>
               <a:rPr lang="en-US" sz="900" kern="0" spc="100" dirty="0">
                 <a:solidFill>
@@ -10647,7 +10590,7 @@
                 <a:ea typeface="Georgia" pitchFamily="34" charset="-122"/>
                 <a:cs typeface="Georgia" pitchFamily="34" charset="-120"/>
               </a:rPr>
-              <a:t>PROYECTO BARBERÍA · WEB + APP MÓVIL</a:t>
+              <a:t>PROYECTO BARBERÍA BIG BOYS · WEB + APP MÓVIL</a:t>
             </a:r>
             <a:endParaRPr lang="en-US" sz="900" dirty="0"/>
           </a:p>
@@ -11513,9 +11456,6 @@
           <a:bodyPr wrap="square" lIns="0" tIns="0" rIns="0" bIns="0" rtlCol="0" anchor="ctr"/>
           <a:lstStyle/>
           <a:p>
-            <a:pPr marL="0" indent="0">
-              <a:buNone/>
-            </a:pPr>
             <a:r>
               <a:rPr lang="en-US" sz="900" kern="0" spc="100" dirty="0">
                 <a:solidFill>
@@ -11525,7 +11465,7 @@
                 <a:ea typeface="Georgia" pitchFamily="34" charset="-122"/>
                 <a:cs typeface="Georgia" pitchFamily="34" charset="-120"/>
               </a:rPr>
-              <a:t>PROYECTO BARBERÍA · WEB + APP MÓVIL</a:t>
+              <a:t>PROYECTO BARBERÍA BIG BOYS · WEB + APP MÓVIL</a:t>
             </a:r>
             <a:endParaRPr lang="en-US" sz="900" dirty="0"/>
           </a:p>
@@ -12308,9 +12248,6 @@
           <a:bodyPr wrap="square" lIns="0" tIns="0" rIns="0" bIns="0" rtlCol="0" anchor="ctr"/>
           <a:lstStyle/>
           <a:p>
-            <a:pPr marL="0" indent="0">
-              <a:buNone/>
-            </a:pPr>
             <a:r>
               <a:rPr lang="en-US" sz="900" kern="0" spc="100" dirty="0">
                 <a:solidFill>
@@ -12320,7 +12257,7 @@
                 <a:ea typeface="Georgia" pitchFamily="34" charset="-122"/>
                 <a:cs typeface="Georgia" pitchFamily="34" charset="-120"/>
               </a:rPr>
-              <a:t>PROYECTO BARBERÍA · WEB + APP MÓVIL</a:t>
+              <a:t>PROYECTO BARBERÍA BIG BOYS · WEB + APP MÓVIL</a:t>
             </a:r>
             <a:endParaRPr lang="en-US" sz="900" dirty="0"/>
           </a:p>
@@ -13457,9 +13394,6 @@
           <a:bodyPr wrap="square" lIns="0" tIns="0" rIns="0" bIns="0" rtlCol="0" anchor="ctr"/>
           <a:lstStyle/>
           <a:p>
-            <a:pPr marL="0" indent="0">
-              <a:buNone/>
-            </a:pPr>
             <a:r>
               <a:rPr lang="en-US" sz="900" kern="0" spc="100" dirty="0">
                 <a:solidFill>
@@ -13469,7 +13403,7 @@
                 <a:ea typeface="Georgia" pitchFamily="34" charset="-122"/>
                 <a:cs typeface="Georgia" pitchFamily="34" charset="-120"/>
               </a:rPr>
-              <a:t>PROYECTO BARBERÍA · WEB + APP MÓVIL</a:t>
+              <a:t>PROYECTO BARBERÍA BIG BOYS · WEB + APP MÓVIL</a:t>
             </a:r>
             <a:endParaRPr lang="en-US" sz="900" dirty="0"/>
           </a:p>

</xml_diff>